<commit_message>
docs(knou): finalize submission documents and externalize personal data
</commit_message>
<xml_diff>
--- a/docs/knou/turtlemeck-presentation.pptx
+++ b/docs/knou/turtlemeck-presentation.pptx
@@ -661,12 +661,7 @@
           <a:lstStyle/>
           <a:p>
             <a:r>
-              <a:t>컴퓨터 작업에 집중하면 머리가 앞으로 이동하거나 상체가 구부러져도 바로 알아차리기 어렵습니다. 일정 시간마다 울리는 일반 알림은 현재 자세가 좋은지와 관계없이 사용자를 방해합니다. 그래서 실제 자세 변화를 확인하되, 별도 장비나 지속적인 영상 저장 없이 사용할 수 있는 도구가 필요하다고 판단했습니다.</a:t>
-            </a:r>
-          </a:p>
-          <a:p>
-            <a:r>
-              <a:t>시간: 40초</a:t>
+              <a:t>이 작품은 팀원의 경험에서 시작했습니다. 하루 종일 노트북 화면만 들여다보면서 목과 어깨가 나빠지는 것을 느꼈고, 최근에는 가족 중 삼촌이 목디스크로 수술을 받았습니다. 그런데 컴퓨터 작업에 집중하면 머리가 앞으로 이동하거나 상체가 구부러져도 바로 알아차리기 어렵고, 일정 시간마다 울리는 일반 알림은 현재 자세와 관계없이 사용자를 방해합니다. 그래서 인공지능 수업에서 배운 내용을 바탕으로, 별도 장비 없이 모든 노트북에 있는 웹캠 하나로 실제 자세 변화를 확인하는 도구를 만들기로 했습니다. 가족과 주변 사람들이 모두 MacBook을 사용하고 있어 macOS 전용 앱으로 개발했습니다.</a:t>
             </a:r>
           </a:p>
         </p:txBody>
@@ -4427,7 +4422,7 @@
                 <a:ea typeface="Pretendard"/>
                 <a:cs typeface="Pretendard"/>
               </a:rPr>
-              <a:t>발표자: [성명]  ·  한국방송통신대학교 컴퓨터과학과</a:t>
+              <a:t>발표자: 김찬형  ·  팀원: 이병묵  —  한국방송통신대학교 컴퓨터과학과</a:t>
             </a:r>
           </a:p>
         </p:txBody>
@@ -5018,7 +5013,7 @@
                 <a:ea typeface="Pretendard"/>
                 <a:cs typeface="Pretendard"/>
               </a:rPr>
-              <a:t>화면에 집중하면 자세 변화를 알아차리기 어려움</a:t>
+              <a:t>장시간 노트북 작업으로 나빠진 목·어깨, 가족의 목디스크 수술 경험</a:t>
             </a:r>
           </a:p>
           <a:p>
@@ -5038,7 +5033,7 @@
                 <a:ea typeface="Pretendard"/>
                 <a:cs typeface="Pretendard"/>
               </a:rPr>
-              <a:t>타이머 알림은 실제 자세와 관계없이 울림</a:t>
+              <a:t>화면에 집중하면 자세 변화를 알아차리기 어려움</a:t>
             </a:r>
           </a:p>
           <a:p>
@@ -5058,7 +5053,27 @@
                 <a:ea typeface="Pretendard"/>
                 <a:cs typeface="Pretendard"/>
               </a:rPr>
-              <a:t>계속 촬영하거나 복잡한 장비를 사용하는 방식은 부담스러움</a:t>
+              <a:t>타이머 알림은 실제 자세와 관계없이 울림</a:t>
+            </a:r>
+          </a:p>
+          <a:p>
+            <a:pPr>
+              <a:spcAft>
+                <a:spcPts val="1800"/>
+              </a:spcAft>
+              <a:buFont typeface="Arial"/>
+              <a:buChar char="•"/>
+            </a:pPr>
+            <a:r>
+              <a:rPr sz="2000" b="0">
+                <a:solidFill>
+                  <a:srgbClr val="1F2937"/>
+                </a:solidFill>
+                <a:latin typeface="Pretendard"/>
+                <a:ea typeface="Pretendard"/>
+                <a:cs typeface="Pretendard"/>
+              </a:rPr>
+              <a:t>수업에서 배운 내용으로, 모든 노트북에 있는 웹캠 하나만 사용</a:t>
             </a:r>
           </a:p>
         </p:txBody>

</xml_diff>